<commit_message>
Corriger les indicateurs d'avancement : 25 capsules expert, capsule PACTE et 76 intro/outro.
Co-authored-by: Cursor <cursoragent@cursor.com>
</commit_message>
<xml_diff>
--- a/avancement-mooc-2026-09-22.pptx
+++ b/avancement-mooc-2026-09-22.pptx
@@ -3155,7 +3155,7 @@
                 </a:solidFill>
                 <a:latin typeface="Arial"/>
               </a:rPr>
-              <a:t>Le dispositif est livré et packagé. L'effort se concentre désormais sur le remplissage.</a:t>
+              <a:t>SPOC Paris-Saclay. Le dispositif est livré et packagé : l'effort porte sur le remplissage.</a:t>
             </a:r>
           </a:p>
         </p:txBody>
@@ -3169,7 +3169,7 @@
         <p:spPr>
           <a:xfrm>
             <a:off x="768096" y="1335024"/>
-            <a:ext cx="1792224" cy="1188720"/>
+            <a:ext cx="1413662" cy="1188720"/>
           </a:xfrm>
           <a:prstGeom prst="roundRect">
             <a:avLst>
@@ -3216,8 +3216,8 @@
         </p:nvSpPr>
         <p:spPr>
           <a:xfrm>
-            <a:off x="822959" y="1463040"/>
-            <a:ext cx="1682495" cy="384048"/>
+            <a:off x="813816" y="1453895"/>
+            <a:ext cx="1322222" cy="347472"/>
           </a:xfrm>
           <a:prstGeom prst="rect">
             <a:avLst/>
@@ -3232,7 +3232,7 @@
           <a:p>
             <a:pPr algn="ctr"/>
             <a:r>
-              <a:rPr sz="2400" b="1">
+              <a:rPr sz="2100" b="1">
                 <a:solidFill>
                   <a:srgbClr val="35BA84"/>
                 </a:solidFill>
@@ -3251,8 +3251,8 @@
         </p:nvSpPr>
         <p:spPr>
           <a:xfrm>
-            <a:off x="822959" y="1883664"/>
-            <a:ext cx="1682495" cy="201168"/>
+            <a:off x="813816" y="1847088"/>
+            <a:ext cx="1322222" cy="182880"/>
           </a:xfrm>
           <a:prstGeom prst="rect">
             <a:avLst/>
@@ -3267,7 +3267,7 @@
           <a:p>
             <a:pPr algn="ctr"/>
             <a:r>
-              <a:rPr sz="1100" b="1">
+              <a:rPr sz="1000" b="1">
                 <a:solidFill>
                   <a:srgbClr val="2A346D"/>
                 </a:solidFill>
@@ -3286,8 +3286,8 @@
         </p:nvSpPr>
         <p:spPr>
           <a:xfrm>
-            <a:off x="841247" y="2112264"/>
-            <a:ext cx="1645920" cy="347472"/>
+            <a:off x="832103" y="2057400"/>
+            <a:ext cx="1285646" cy="402336"/>
           </a:xfrm>
           <a:prstGeom prst="rect">
             <a:avLst/>
@@ -3302,7 +3302,7 @@
           <a:p>
             <a:pPr algn="ctr"/>
             <a:r>
-              <a:rPr sz="850" b="0">
+              <a:rPr sz="800" b="0">
                 <a:solidFill>
                   <a:srgbClr val="475569"/>
                 </a:solidFill>
@@ -3321,8 +3321,8 @@
         </p:nvSpPr>
         <p:spPr>
           <a:xfrm>
-            <a:off x="2734056" y="1335024"/>
-            <a:ext cx="1792224" cy="1188720"/>
+            <a:off x="2337206" y="1335024"/>
+            <a:ext cx="1413662" cy="1188720"/>
           </a:xfrm>
           <a:prstGeom prst="roundRect">
             <a:avLst>
@@ -3369,8 +3369,8 @@
         </p:nvSpPr>
         <p:spPr>
           <a:xfrm>
-            <a:off x="2788920" y="1463040"/>
-            <a:ext cx="1682495" cy="384048"/>
+            <a:off x="2382926" y="1453895"/>
+            <a:ext cx="1322222" cy="347472"/>
           </a:xfrm>
           <a:prstGeom prst="rect">
             <a:avLst/>
@@ -3385,13 +3385,13 @@
           <a:p>
             <a:pPr algn="ctr"/>
             <a:r>
-              <a:rPr sz="2400" b="1">
+              <a:rPr sz="2100" b="1">
                 <a:solidFill>
                   <a:srgbClr val="F6862C"/>
                 </a:solidFill>
                 <a:latin typeface="Arial"/>
               </a:rPr>
-              <a:t>14 / 23</a:t>
+              <a:t>15 / 25</a:t>
             </a:r>
           </a:p>
         </p:txBody>
@@ -3404,8 +3404,8 @@
         </p:nvSpPr>
         <p:spPr>
           <a:xfrm>
-            <a:off x="2788920" y="1883664"/>
-            <a:ext cx="1682495" cy="201168"/>
+            <a:off x="2382926" y="1847088"/>
+            <a:ext cx="1322222" cy="182880"/>
           </a:xfrm>
           <a:prstGeom prst="rect">
             <a:avLst/>
@@ -3420,7 +3420,7 @@
           <a:p>
             <a:pPr algn="ctr"/>
             <a:r>
-              <a:rPr sz="1100" b="1">
+              <a:rPr sz="1000" b="1">
                 <a:solidFill>
                   <a:srgbClr val="2A346D"/>
                 </a:solidFill>
@@ -3439,8 +3439,8 @@
         </p:nvSpPr>
         <p:spPr>
           <a:xfrm>
-            <a:off x="2807208" y="2112264"/>
-            <a:ext cx="1645920" cy="347472"/>
+            <a:off x="2401214" y="2057400"/>
+            <a:ext cx="1285646" cy="402336"/>
           </a:xfrm>
           <a:prstGeom prst="rect">
             <a:avLst/>
@@ -3455,7 +3455,7 @@
           <a:p>
             <a:pPr algn="ctr"/>
             <a:r>
-              <a:rPr sz="850" b="0">
+              <a:rPr sz="800" b="0">
                 <a:solidFill>
                   <a:srgbClr val="475569"/>
                 </a:solidFill>
@@ -3474,8 +3474,8 @@
         </p:nvSpPr>
         <p:spPr>
           <a:xfrm>
-            <a:off x="4700016" y="1335024"/>
-            <a:ext cx="1792224" cy="1188720"/>
+            <a:off x="3906316" y="1335024"/>
+            <a:ext cx="1413662" cy="1188720"/>
           </a:xfrm>
           <a:prstGeom prst="roundRect">
             <a:avLst>
@@ -3522,8 +3522,8 @@
         </p:nvSpPr>
         <p:spPr>
           <a:xfrm>
-            <a:off x="4754879" y="1463040"/>
-            <a:ext cx="1682495" cy="384048"/>
+            <a:off x="3952036" y="1453895"/>
+            <a:ext cx="1322222" cy="347472"/>
           </a:xfrm>
           <a:prstGeom prst="rect">
             <a:avLst/>
@@ -3538,13 +3538,13 @@
           <a:p>
             <a:pPr algn="ctr"/>
             <a:r>
-              <a:rPr sz="2400" b="1">
+              <a:rPr sz="2100" b="1">
                 <a:solidFill>
                   <a:srgbClr val="63003D"/>
                 </a:solidFill>
                 <a:latin typeface="Arial"/>
               </a:rPr>
-              <a:t>0 / 36</a:t>
+              <a:t>0 / 38</a:t>
             </a:r>
           </a:p>
         </p:txBody>
@@ -3557,8 +3557,8 @@
         </p:nvSpPr>
         <p:spPr>
           <a:xfrm>
-            <a:off x="4754879" y="1883664"/>
-            <a:ext cx="1682495" cy="201168"/>
+            <a:off x="3952036" y="1847088"/>
+            <a:ext cx="1322222" cy="182880"/>
           </a:xfrm>
           <a:prstGeom prst="rect">
             <a:avLst/>
@@ -3573,7 +3573,7 @@
           <a:p>
             <a:pPr algn="ctr"/>
             <a:r>
-              <a:rPr sz="1100" b="1">
+              <a:rPr sz="1000" b="1">
                 <a:solidFill>
                   <a:srgbClr val="2A346D"/>
                 </a:solidFill>
@@ -3592,8 +3592,8 @@
         </p:nvSpPr>
         <p:spPr>
           <a:xfrm>
-            <a:off x="4773168" y="2112264"/>
-            <a:ext cx="1645920" cy="347472"/>
+            <a:off x="3970324" y="2057400"/>
+            <a:ext cx="1285646" cy="402336"/>
           </a:xfrm>
           <a:prstGeom prst="rect">
             <a:avLst/>
@@ -3608,13 +3608,13 @@
           <a:p>
             <a:pPr algn="ctr"/>
             <a:r>
-              <a:rPr sz="850" b="0">
+              <a:rPr sz="800" b="0">
                 <a:solidFill>
                   <a:srgbClr val="475569"/>
                 </a:solidFill>
                 <a:latin typeface="Arial"/>
               </a:rPr>
-              <a:t>36 emplacements câblés, 0 rempli</a:t>
+              <a:t>37 emplacements câblés · 1 à créer</a:t>
             </a:r>
           </a:p>
         </p:txBody>
@@ -3627,8 +3627,8 @@
         </p:nvSpPr>
         <p:spPr>
           <a:xfrm>
-            <a:off x="6665975" y="1335024"/>
-            <a:ext cx="1792224" cy="1188720"/>
+            <a:off x="5475427" y="1335024"/>
+            <a:ext cx="1413662" cy="1188720"/>
           </a:xfrm>
           <a:prstGeom prst="roundRect">
             <a:avLst>
@@ -3675,8 +3675,8 @@
         </p:nvSpPr>
         <p:spPr>
           <a:xfrm>
-            <a:off x="6720839" y="1463040"/>
-            <a:ext cx="1682495" cy="384048"/>
+            <a:off x="5521147" y="1453895"/>
+            <a:ext cx="1322222" cy="347472"/>
           </a:xfrm>
           <a:prstGeom prst="rect">
             <a:avLst/>
@@ -3691,13 +3691,13 @@
           <a:p>
             <a:pPr algn="ctr"/>
             <a:r>
-              <a:rPr sz="2400" b="1">
+              <a:rPr sz="2100" b="1">
                 <a:solidFill>
                   <a:srgbClr val="2A346D"/>
                 </a:solidFill>
                 <a:latin typeface="Arial"/>
               </a:rPr>
-              <a:t>176</a:t>
+              <a:t>76</a:t>
             </a:r>
           </a:p>
         </p:txBody>
@@ -3710,8 +3710,8 @@
         </p:nvSpPr>
         <p:spPr>
           <a:xfrm>
-            <a:off x="6720839" y="1883664"/>
-            <a:ext cx="1682495" cy="201168"/>
+            <a:off x="5521147" y="1847088"/>
+            <a:ext cx="1322222" cy="182880"/>
           </a:xfrm>
           <a:prstGeom prst="rect">
             <a:avLst/>
@@ -3726,13 +3726,13 @@
           <a:p>
             <a:pPr algn="ctr"/>
             <a:r>
-              <a:rPr sz="1100" b="1">
+              <a:rPr sz="1000" b="1">
                 <a:solidFill>
                   <a:srgbClr val="2A346D"/>
                 </a:solidFill>
                 <a:latin typeface="Arial"/>
               </a:rPr>
-              <a:t>Incrustations</a:t>
+              <a:t>Intro / outro</a:t>
             </a:r>
           </a:p>
         </p:txBody>
@@ -3745,8 +3745,8 @@
         </p:nvSpPr>
         <p:spPr>
           <a:xfrm>
-            <a:off x="6739127" y="2112264"/>
-            <a:ext cx="1645920" cy="347472"/>
+            <a:off x="5539435" y="2057400"/>
+            <a:ext cx="1285646" cy="402336"/>
           </a:xfrm>
           <a:prstGeom prst="rect">
             <a:avLst/>
@@ -3761,66 +3761,31 @@
           <a:p>
             <a:pPr algn="ctr"/>
             <a:r>
-              <a:rPr sz="850" b="0">
+              <a:rPr sz="800" b="0">
                 <a:solidFill>
                   <a:srgbClr val="475569"/>
                 </a:solidFill>
                 <a:latin typeface="Arial"/>
               </a:rPr>
-              <a:t>propositions à arbitrer</a:t>
-            </a:r>
-          </a:p>
-        </p:txBody>
-      </p:sp>
-      <p:sp>
-        <p:nvSpPr>
-          <p:cNvPr id="20" name="TextBox 19"/>
-          <p:cNvSpPr txBox="1"/>
-          <p:nvPr/>
-        </p:nvSpPr>
-        <p:spPr>
-          <a:xfrm>
-            <a:off x="768096" y="2743200"/>
-            <a:ext cx="7690104" cy="219456"/>
-          </a:xfrm>
-          <a:prstGeom prst="rect">
-            <a:avLst/>
-          </a:prstGeom>
-          <a:noFill/>
-        </p:spPr>
-        <p:txBody>
-          <a:bodyPr wrap="square" lIns="0" rIns="0" tIns="0" bIns="0" anchor="t">
-            <a:spAutoFit/>
-          </a:bodyPr>
-          <a:lstStyle/>
-          <a:p>
-            <a:pPr algn="l"/>
-            <a:r>
-              <a:rPr sz="1250" b="1">
-                <a:solidFill>
-                  <a:srgbClr val="2A346D"/>
-                </a:solidFill>
-                <a:latin typeface="Arial"/>
-              </a:rPr>
-              <a:t>État des rushes expert par module</a:t>
-            </a:r>
-          </a:p>
-        </p:txBody>
-      </p:sp>
-      <p:sp>
-        <p:nvSpPr>
-          <p:cNvPr id="21" name="Rounded Rectangle 20"/>
+              <a:t>segments · 40 à 57 min à produire</a:t>
+            </a:r>
+          </a:p>
+        </p:txBody>
+      </p:sp>
+      <p:sp>
+        <p:nvSpPr>
+          <p:cNvPr id="20" name="Rounded Rectangle 19"/>
           <p:cNvSpPr/>
           <p:nvPr/>
         </p:nvSpPr>
         <p:spPr>
           <a:xfrm>
-            <a:off x="768096" y="3035808"/>
-            <a:ext cx="996696" cy="566928"/>
+            <a:off x="7044537" y="1335024"/>
+            <a:ext cx="1413662" cy="1188720"/>
           </a:xfrm>
           <a:prstGeom prst="roundRect">
             <a:avLst>
-              <a:gd name="adj" fmla="val 12000"/>
+              <a:gd name="adj" fmla="val 16667"/>
             </a:avLst>
           </a:prstGeom>
           <a:solidFill>
@@ -3857,7 +3822,195 @@
       </p:sp>
       <p:sp>
         <p:nvSpPr>
+          <p:cNvPr id="21" name="TextBox 20"/>
+          <p:cNvSpPr txBox="1"/>
+          <p:nvPr/>
+        </p:nvSpPr>
+        <p:spPr>
+          <a:xfrm>
+            <a:off x="7090257" y="1453895"/>
+            <a:ext cx="1322222" cy="347472"/>
+          </a:xfrm>
+          <a:prstGeom prst="rect">
+            <a:avLst/>
+          </a:prstGeom>
+          <a:noFill/>
+        </p:spPr>
+        <p:txBody>
+          <a:bodyPr wrap="square" lIns="0" rIns="0" tIns="0" bIns="0" anchor="t">
+            <a:spAutoFit/>
+          </a:bodyPr>
+          <a:lstStyle/>
+          <a:p>
+            <a:pPr algn="ctr"/>
+            <a:r>
+              <a:rPr sz="2100" b="1">
+                <a:solidFill>
+                  <a:srgbClr val="35BA84"/>
+                </a:solidFill>
+                <a:latin typeface="Arial"/>
+              </a:rPr>
+              <a:t>176</a:t>
+            </a:r>
+          </a:p>
+        </p:txBody>
+      </p:sp>
+      <p:sp>
+        <p:nvSpPr>
           <p:cNvPr id="22" name="TextBox 21"/>
+          <p:cNvSpPr txBox="1"/>
+          <p:nvPr/>
+        </p:nvSpPr>
+        <p:spPr>
+          <a:xfrm>
+            <a:off x="7090257" y="1847088"/>
+            <a:ext cx="1322222" cy="182880"/>
+          </a:xfrm>
+          <a:prstGeom prst="rect">
+            <a:avLst/>
+          </a:prstGeom>
+          <a:noFill/>
+        </p:spPr>
+        <p:txBody>
+          <a:bodyPr wrap="square" lIns="0" rIns="0" tIns="0" bIns="0" anchor="t">
+            <a:spAutoFit/>
+          </a:bodyPr>
+          <a:lstStyle/>
+          <a:p>
+            <a:pPr algn="ctr"/>
+            <a:r>
+              <a:rPr sz="1000" b="1">
+                <a:solidFill>
+                  <a:srgbClr val="2A346D"/>
+                </a:solidFill>
+                <a:latin typeface="Arial"/>
+              </a:rPr>
+              <a:t>Incrustations</a:t>
+            </a:r>
+          </a:p>
+        </p:txBody>
+      </p:sp>
+      <p:sp>
+        <p:nvSpPr>
+          <p:cNvPr id="23" name="TextBox 22"/>
+          <p:cNvSpPr txBox="1"/>
+          <p:nvPr/>
+        </p:nvSpPr>
+        <p:spPr>
+          <a:xfrm>
+            <a:off x="7108545" y="2057400"/>
+            <a:ext cx="1285646" cy="402336"/>
+          </a:xfrm>
+          <a:prstGeom prst="rect">
+            <a:avLst/>
+          </a:prstGeom>
+          <a:noFill/>
+        </p:spPr>
+        <p:txBody>
+          <a:bodyPr wrap="square" lIns="0" rIns="0" tIns="0" bIns="0" anchor="t">
+            <a:spAutoFit/>
+          </a:bodyPr>
+          <a:lstStyle/>
+          <a:p>
+            <a:pPr algn="ctr"/>
+            <a:r>
+              <a:rPr sz="800" b="0">
+                <a:solidFill>
+                  <a:srgbClr val="475569"/>
+                </a:solidFill>
+                <a:latin typeface="Arial"/>
+              </a:rPr>
+              <a:t>propositions à arbitrer</a:t>
+            </a:r>
+          </a:p>
+        </p:txBody>
+      </p:sp>
+      <p:sp>
+        <p:nvSpPr>
+          <p:cNvPr id="24" name="TextBox 23"/>
+          <p:cNvSpPr txBox="1"/>
+          <p:nvPr/>
+        </p:nvSpPr>
+        <p:spPr>
+          <a:xfrm>
+            <a:off x="768096" y="2743200"/>
+            <a:ext cx="7690104" cy="219456"/>
+          </a:xfrm>
+          <a:prstGeom prst="rect">
+            <a:avLst/>
+          </a:prstGeom>
+          <a:noFill/>
+        </p:spPr>
+        <p:txBody>
+          <a:bodyPr wrap="square" lIns="0" rIns="0" tIns="0" bIns="0" anchor="t">
+            <a:spAutoFit/>
+          </a:bodyPr>
+          <a:lstStyle/>
+          <a:p>
+            <a:pPr algn="l"/>
+            <a:r>
+              <a:rPr sz="1250" b="1">
+                <a:solidFill>
+                  <a:srgbClr val="2A346D"/>
+                </a:solidFill>
+                <a:latin typeface="Arial"/>
+              </a:rPr>
+              <a:t>État des rushes expert par module</a:t>
+            </a:r>
+          </a:p>
+        </p:txBody>
+      </p:sp>
+      <p:sp>
+        <p:nvSpPr>
+          <p:cNvPr id="25" name="Rounded Rectangle 24"/>
+          <p:cNvSpPr/>
+          <p:nvPr/>
+        </p:nvSpPr>
+        <p:spPr>
+          <a:xfrm>
+            <a:off x="768096" y="3035808"/>
+            <a:ext cx="996696" cy="566928"/>
+          </a:xfrm>
+          <a:prstGeom prst="roundRect">
+            <a:avLst>
+              <a:gd name="adj" fmla="val 12000"/>
+            </a:avLst>
+          </a:prstGeom>
+          <a:solidFill>
+            <a:srgbClr val="ECFAF4"/>
+          </a:solidFill>
+          <a:ln w="15875">
+            <a:solidFill>
+              <a:srgbClr val="35BA84"/>
+            </a:solidFill>
+          </a:ln>
+          <a:effectLst/>
+        </p:spPr>
+        <p:style>
+          <a:lnRef idx="1">
+            <a:schemeClr val="accent1"/>
+          </a:lnRef>
+          <a:fillRef idx="3">
+            <a:schemeClr val="accent1"/>
+          </a:fillRef>
+          <a:effectRef idx="2">
+            <a:schemeClr val="accent1"/>
+          </a:effectRef>
+          <a:fontRef idx="minor">
+            <a:schemeClr val="lt1"/>
+          </a:fontRef>
+        </p:style>
+        <p:txBody>
+          <a:bodyPr rtlCol="0" anchor="ctr" wrap="square"/>
+          <a:lstStyle/>
+          <a:p>
+            <a:pPr algn="ctr"/>
+          </a:p>
+        </p:txBody>
+      </p:sp>
+      <p:sp>
+        <p:nvSpPr>
+          <p:cNvPr id="26" name="TextBox 25"/>
           <p:cNvSpPr txBox="1"/>
           <p:nvPr/>
         </p:nvSpPr>
@@ -3892,7 +4045,7 @@
       </p:sp>
       <p:sp>
         <p:nvSpPr>
-          <p:cNvPr id="23" name="TextBox 22"/>
+          <p:cNvPr id="27" name="TextBox 26"/>
           <p:cNvSpPr txBox="1"/>
           <p:nvPr/>
         </p:nvSpPr>
@@ -3927,7 +4080,7 @@
       </p:sp>
       <p:sp>
         <p:nvSpPr>
-          <p:cNvPr id="24" name="Rounded Rectangle 23"/>
+          <p:cNvPr id="28" name="Rounded Rectangle 27"/>
           <p:cNvSpPr/>
           <p:nvPr/>
         </p:nvSpPr>
@@ -3975,7 +4128,7 @@
       </p:sp>
       <p:sp>
         <p:nvSpPr>
-          <p:cNvPr id="25" name="TextBox 24"/>
+          <p:cNvPr id="29" name="TextBox 28"/>
           <p:cNvSpPr txBox="1"/>
           <p:nvPr/>
         </p:nvSpPr>
@@ -4010,7 +4163,7 @@
       </p:sp>
       <p:sp>
         <p:nvSpPr>
-          <p:cNvPr id="26" name="TextBox 25"/>
+          <p:cNvPr id="30" name="TextBox 29"/>
           <p:cNvSpPr txBox="1"/>
           <p:nvPr/>
         </p:nvSpPr>
@@ -4045,7 +4198,7 @@
       </p:sp>
       <p:sp>
         <p:nvSpPr>
-          <p:cNvPr id="27" name="Rounded Rectangle 26"/>
+          <p:cNvPr id="31" name="Rounded Rectangle 30"/>
           <p:cNvSpPr/>
           <p:nvPr/>
         </p:nvSpPr>
@@ -4093,7 +4246,7 @@
       </p:sp>
       <p:sp>
         <p:nvSpPr>
-          <p:cNvPr id="28" name="TextBox 27"/>
+          <p:cNvPr id="32" name="TextBox 31"/>
           <p:cNvSpPr txBox="1"/>
           <p:nvPr/>
         </p:nvSpPr>
@@ -4128,7 +4281,7 @@
       </p:sp>
       <p:sp>
         <p:nvSpPr>
-          <p:cNvPr id="29" name="TextBox 28"/>
+          <p:cNvPr id="33" name="TextBox 32"/>
           <p:cNvSpPr txBox="1"/>
           <p:nvPr/>
         </p:nvSpPr>
@@ -4163,7 +4316,7 @@
       </p:sp>
       <p:sp>
         <p:nvSpPr>
-          <p:cNvPr id="30" name="Rounded Rectangle 29"/>
+          <p:cNvPr id="34" name="Rounded Rectangle 33"/>
           <p:cNvSpPr/>
           <p:nvPr/>
         </p:nvSpPr>
@@ -4211,7 +4364,7 @@
       </p:sp>
       <p:sp>
         <p:nvSpPr>
-          <p:cNvPr id="31" name="TextBox 30"/>
+          <p:cNvPr id="35" name="TextBox 34"/>
           <p:cNvSpPr txBox="1"/>
           <p:nvPr/>
         </p:nvSpPr>
@@ -4246,7 +4399,7 @@
       </p:sp>
       <p:sp>
         <p:nvSpPr>
-          <p:cNvPr id="32" name="TextBox 31"/>
+          <p:cNvPr id="36" name="TextBox 35"/>
           <p:cNvSpPr txBox="1"/>
           <p:nvPr/>
         </p:nvSpPr>
@@ -4281,7 +4434,7 @@
       </p:sp>
       <p:sp>
         <p:nvSpPr>
-          <p:cNvPr id="33" name="Rounded Rectangle 32"/>
+          <p:cNvPr id="37" name="Rounded Rectangle 36"/>
           <p:cNvSpPr/>
           <p:nvPr/>
         </p:nvSpPr>
@@ -4329,7 +4482,7 @@
       </p:sp>
       <p:sp>
         <p:nvSpPr>
-          <p:cNvPr id="34" name="TextBox 33"/>
+          <p:cNvPr id="38" name="TextBox 37"/>
           <p:cNvSpPr txBox="1"/>
           <p:nvPr/>
         </p:nvSpPr>
@@ -4364,7 +4517,7 @@
       </p:sp>
       <p:sp>
         <p:nvSpPr>
-          <p:cNvPr id="35" name="TextBox 34"/>
+          <p:cNvPr id="39" name="TextBox 38"/>
           <p:cNvSpPr txBox="1"/>
           <p:nvPr/>
         </p:nvSpPr>
@@ -4399,7 +4552,7 @@
       </p:sp>
       <p:sp>
         <p:nvSpPr>
-          <p:cNvPr id="36" name="Rounded Rectangle 35"/>
+          <p:cNvPr id="40" name="Rounded Rectangle 39"/>
           <p:cNvSpPr/>
           <p:nvPr/>
         </p:nvSpPr>
@@ -4447,7 +4600,7 @@
       </p:sp>
       <p:sp>
         <p:nvSpPr>
-          <p:cNvPr id="37" name="TextBox 36"/>
+          <p:cNvPr id="41" name="TextBox 40"/>
           <p:cNvSpPr txBox="1"/>
           <p:nvPr/>
         </p:nvSpPr>
@@ -4482,7 +4635,7 @@
       </p:sp>
       <p:sp>
         <p:nvSpPr>
-          <p:cNvPr id="38" name="TextBox 37"/>
+          <p:cNvPr id="42" name="TextBox 41"/>
           <p:cNvSpPr txBox="1"/>
           <p:nvPr/>
         </p:nvSpPr>
@@ -4517,7 +4670,7 @@
       </p:sp>
       <p:sp>
         <p:nvSpPr>
-          <p:cNvPr id="39" name="Rounded Rectangle 38"/>
+          <p:cNvPr id="43" name="Rounded Rectangle 42"/>
           <p:cNvSpPr/>
           <p:nvPr/>
         </p:nvSpPr>
@@ -4565,7 +4718,7 @@
       </p:sp>
       <p:sp>
         <p:nvSpPr>
-          <p:cNvPr id="40" name="TextBox 39"/>
+          <p:cNvPr id="44" name="TextBox 43"/>
           <p:cNvSpPr txBox="1"/>
           <p:nvPr/>
         </p:nvSpPr>
@@ -4600,7 +4753,7 @@
       </p:sp>
       <p:sp>
         <p:nvSpPr>
-          <p:cNvPr id="41" name="TextBox 40"/>
+          <p:cNvPr id="45" name="TextBox 44"/>
           <p:cNvSpPr txBox="1"/>
           <p:nvPr/>
         </p:nvSpPr>
@@ -4635,7 +4788,7 @@
       </p:sp>
       <p:sp>
         <p:nvSpPr>
-          <p:cNvPr id="42" name="TextBox 41"/>
+          <p:cNvPr id="46" name="TextBox 45"/>
           <p:cNvSpPr txBox="1"/>
           <p:nvPr/>
         </p:nvSpPr>
@@ -4663,14 +4816,14 @@
                 </a:solidFill>
                 <a:latin typeface="Arial"/>
               </a:rPr>
-              <a:t>Les 3 modules verts sont intégrables dès validation des V1 témoin et V0 expert.</a:t>
-            </a:r>
-          </a:p>
-        </p:txBody>
-      </p:sp>
-      <p:sp>
-        <p:nvSpPr>
-          <p:cNvPr id="43" name="Rounded Rectangle 42"/>
+              <a:t>Les 4 modules verts sont intégrables dès validation des V1/V0 — mais M2 ou M5 accueillera la capsule PACTE.</a:t>
+            </a:r>
+          </a:p>
+        </p:txBody>
+      </p:sp>
+      <p:sp>
+        <p:nvSpPr>
+          <p:cNvPr id="47" name="Rounded Rectangle 46"/>
           <p:cNvSpPr/>
           <p:nvPr/>
         </p:nvSpPr>
@@ -4718,7 +4871,7 @@
       </p:sp>
       <p:sp>
         <p:nvSpPr>
-          <p:cNvPr id="44" name="TextBox 43"/>
+          <p:cNvPr id="48" name="TextBox 47"/>
           <p:cNvSpPr txBox="1"/>
           <p:nvPr/>
         </p:nvSpPr>
@@ -4753,7 +4906,7 @@
       </p:sp>
       <p:sp>
         <p:nvSpPr>
-          <p:cNvPr id="45" name="TextBox 44"/>
+          <p:cNvPr id="49" name="TextBox 48"/>
           <p:cNvSpPr txBox="1"/>
           <p:nvPr/>
         </p:nvSpPr>
@@ -4788,7 +4941,7 @@
       </p:sp>
       <p:sp>
         <p:nvSpPr>
-          <p:cNvPr id="46" name="TextBox 45"/>
+          <p:cNvPr id="50" name="TextBox 49"/>
           <p:cNvSpPr txBox="1"/>
           <p:nvPr/>
         </p:nvSpPr>
@@ -4869,7 +5022,7 @@
                 </a:solidFill>
                 <a:latin typeface="Arial"/>
               </a:rPr>
-              <a:t>Trois décisions attendues</a:t>
+              <a:t>Quatre points à trancher</a:t>
             </a:r>
           </a:p>
         </p:txBody>
@@ -4904,7 +5057,7 @@
                 </a:solidFill>
                 <a:latin typeface="Arial"/>
               </a:rPr>
-              <a:t>Le calendrier ne tient que si ces trois points sont tranchés cette semaine.</a:t>
+              <a:t>Le calendrier ne tient que si ces quatre points sont arbitrés dans les prochains jours.</a:t>
             </a:r>
           </a:p>
         </p:txBody>
@@ -4918,7 +5071,7 @@
         <p:spPr>
           <a:xfrm>
             <a:off x="768096" y="1335024"/>
-            <a:ext cx="2411272" cy="2487168"/>
+            <a:ext cx="1751076" cy="2487168"/>
           </a:xfrm>
           <a:prstGeom prst="roundRect">
             <a:avLst>
@@ -4963,8 +5116,8 @@
         </p:nvSpPr>
         <p:spPr>
           <a:xfrm>
-            <a:off x="1735988" y="1517904"/>
-            <a:ext cx="475488" cy="475488"/>
+            <a:off x="1424178" y="1517904"/>
+            <a:ext cx="438912" cy="438912"/>
           </a:xfrm>
           <a:prstGeom prst="ellipse">
             <a:avLst/>
@@ -4997,7 +5150,7 @@
           <a:p>
             <a:pPr algn="ctr"/>
             <a:r>
-              <a:rPr sz="1800" b="1">
+              <a:rPr sz="1600" b="1">
                 <a:solidFill>
                   <a:srgbClr val="FFFFFF"/>
                 </a:solidFill>
@@ -5016,8 +5169,8 @@
         </p:nvSpPr>
         <p:spPr>
           <a:xfrm>
-            <a:off x="914400" y="2121408"/>
-            <a:ext cx="2118664" cy="237744"/>
+            <a:off x="877824" y="2084831"/>
+            <a:ext cx="1531620" cy="256032"/>
           </a:xfrm>
           <a:prstGeom prst="rect">
             <a:avLst/>
@@ -5032,13 +5185,13 @@
           <a:p>
             <a:pPr algn="ctr"/>
             <a:r>
-              <a:rPr sz="1250" b="1">
+              <a:rPr sz="1150" b="1">
                 <a:solidFill>
                   <a:srgbClr val="63003D"/>
                 </a:solidFill>
                 <a:latin typeface="Arial"/>
               </a:rPr>
-              <a:t>E12 / E14 — Fatoumata</a:t>
+              <a:t>E12 / E14</a:t>
             </a:r>
           </a:p>
         </p:txBody>
@@ -5051,8 +5204,8 @@
         </p:nvSpPr>
         <p:spPr>
           <a:xfrm>
-            <a:off x="932688" y="2395728"/>
-            <a:ext cx="2082088" cy="566928"/>
+            <a:off x="896112" y="2377439"/>
+            <a:ext cx="1495044" cy="621792"/>
           </a:xfrm>
           <a:prstGeom prst="rect">
             <a:avLst/>
@@ -5067,13 +5220,13 @@
           <a:p>
             <a:pPr algn="ctr"/>
             <a:r>
-              <a:rPr sz="950" b="0">
+              <a:rPr sz="900" b="0">
                 <a:solidFill>
                   <a:srgbClr val="475569"/>
                 </a:solidFill>
                 <a:latin typeface="Arial"/>
               </a:rPr>
-              <a:t>Au planning du 11/09, non importées en V0. Absentes du plateau du 24/09.</a:t>
+              <a:t>Capsules Fatoumata, non importées en V0 et absentes du 24/09.</a:t>
             </a:r>
           </a:p>
         </p:txBody>
@@ -5086,8 +5239,8 @@
         </p:nvSpPr>
         <p:spPr>
           <a:xfrm>
-            <a:off x="914400" y="3054096"/>
-            <a:ext cx="2118664" cy="237744"/>
+            <a:off x="877824" y="3072384"/>
+            <a:ext cx="1531620" cy="256032"/>
           </a:xfrm>
           <a:prstGeom prst="rect">
             <a:avLst/>
@@ -5102,13 +5255,13 @@
           <a:p>
             <a:pPr algn="ctr"/>
             <a:r>
-              <a:rPr sz="1100" b="1">
+              <a:rPr sz="950" b="1">
                 <a:solidFill>
                   <a:srgbClr val="2A346D"/>
                 </a:solidFill>
                 <a:latin typeface="Arial"/>
               </a:rPr>
-              <a:t>Bloque 100 % du module 3</a:t>
+              <a:t>Bloque le module 3</a:t>
             </a:r>
           </a:p>
         </p:txBody>
@@ -5121,8 +5274,8 @@
         </p:nvSpPr>
         <p:spPr>
           <a:xfrm>
-            <a:off x="932688" y="3328416"/>
-            <a:ext cx="2082088" cy="365760"/>
+            <a:off x="896112" y="3364992"/>
+            <a:ext cx="1495044" cy="384048"/>
           </a:xfrm>
           <a:prstGeom prst="rect">
             <a:avLst/>
@@ -5137,13 +5290,13 @@
           <a:p>
             <a:pPr algn="ctr"/>
             <a:r>
-              <a:rPr sz="850" b="0">
+              <a:rPr sz="800" b="0">
                 <a:solidFill>
                   <a:srgbClr val="64748B"/>
                 </a:solidFill>
                 <a:latin typeface="Arial"/>
               </a:rPr>
-              <a:t>T7 = E12 + E13 · T8 = E14 + E15</a:t>
+              <a:t>T7 et T8 incomplets</a:t>
             </a:r>
           </a:p>
         </p:txBody>
@@ -5156,8 +5309,8 @@
         </p:nvSpPr>
         <p:spPr>
           <a:xfrm>
-            <a:off x="3407968" y="1335024"/>
-            <a:ext cx="2411272" cy="2487168"/>
+            <a:off x="2747772" y="1335024"/>
+            <a:ext cx="1751076" cy="2487168"/>
           </a:xfrm>
           <a:prstGeom prst="roundRect">
             <a:avLst>
@@ -5202,8 +5355,8 @@
         </p:nvSpPr>
         <p:spPr>
           <a:xfrm>
-            <a:off x="4375861" y="1517904"/>
-            <a:ext cx="475488" cy="475488"/>
+            <a:off x="3403854" y="1517904"/>
+            <a:ext cx="438912" cy="438912"/>
           </a:xfrm>
           <a:prstGeom prst="ellipse">
             <a:avLst/>
@@ -5236,7 +5389,7 @@
           <a:p>
             <a:pPr algn="ctr"/>
             <a:r>
-              <a:rPr sz="1800" b="1">
+              <a:rPr sz="1600" b="1">
                 <a:solidFill>
                   <a:srgbClr val="FFFFFF"/>
                 </a:solidFill>
@@ -5255,8 +5408,8 @@
         </p:nvSpPr>
         <p:spPr>
           <a:xfrm>
-            <a:off x="3554272" y="2121408"/>
-            <a:ext cx="2118664" cy="237744"/>
+            <a:off x="2857500" y="2084831"/>
+            <a:ext cx="1531620" cy="256032"/>
           </a:xfrm>
           <a:prstGeom prst="rect">
             <a:avLst/>
@@ -5271,13 +5424,13 @@
           <a:p>
             <a:pPr algn="ctr"/>
             <a:r>
-              <a:rPr sz="1250" b="1">
+              <a:rPr sz="1150" b="1">
                 <a:solidFill>
                   <a:srgbClr val="F6862C"/>
                 </a:solidFill>
                 <a:latin typeface="Arial"/>
               </a:rPr>
-              <a:t>Décompte des experts</a:t>
+              <a:t>Capsule loi PACTE</a:t>
             </a:r>
           </a:p>
         </p:txBody>
@@ -5290,8 +5443,8 @@
         </p:nvSpPr>
         <p:spPr>
           <a:xfrm>
-            <a:off x="3572560" y="2395728"/>
-            <a:ext cx="2082088" cy="566928"/>
+            <a:off x="2875788" y="2377439"/>
+            <a:ext cx="1495044" cy="621792"/>
           </a:xfrm>
           <a:prstGeom prst="rect">
             <a:avLst/>
@@ -5306,13 +5459,13 @@
           <a:p>
             <a:pPr algn="ctr"/>
             <a:r>
-              <a:rPr sz="950" b="0">
+              <a:rPr sz="900" b="0">
                 <a:solidFill>
                   <a:srgbClr val="475569"/>
                 </a:solidFill>
                 <a:latin typeface="Arial"/>
               </a:rPr>
-              <a:t>L'architecture donne 14 capsules filmées, 15 sont annoncées.</a:t>
+              <a:t>Sujet apparu en captation, sans emplacement prévu.</a:t>
             </a:r>
           </a:p>
         </p:txBody>
@@ -5325,8 +5478,8 @@
         </p:nvSpPr>
         <p:spPr>
           <a:xfrm>
-            <a:off x="3554272" y="3054096"/>
-            <a:ext cx="2118664" cy="237744"/>
+            <a:off x="2857500" y="3072384"/>
+            <a:ext cx="1531620" cy="256032"/>
           </a:xfrm>
           <a:prstGeom prst="rect">
             <a:avLst/>
@@ -5341,13 +5494,13 @@
           <a:p>
             <a:pPr algn="ctr"/>
             <a:r>
-              <a:rPr sz="1100" b="1">
+              <a:rPr sz="950" b="1">
                 <a:solidFill>
                   <a:srgbClr val="2A346D"/>
                 </a:solidFill>
                 <a:latin typeface="Arial"/>
               </a:rPr>
-              <a:t>23 ou 24 emplacements ?</a:t>
+              <a:t>M2 ou M5 à arbitrer</a:t>
             </a:r>
           </a:p>
         </p:txBody>
@@ -5360,8 +5513,8 @@
         </p:nvSpPr>
         <p:spPr>
           <a:xfrm>
-            <a:off x="3572560" y="3328416"/>
-            <a:ext cx="2082088" cy="365760"/>
+            <a:off x="2875788" y="3364992"/>
+            <a:ext cx="1495044" cy="384048"/>
           </a:xfrm>
           <a:prstGeom prst="rect">
             <a:avLst/>
@@ -5376,13 +5529,13 @@
           <a:p>
             <a:pPr algn="ctr"/>
             <a:r>
-              <a:rPr sz="850" b="0">
+              <a:rPr sz="800" b="0">
                 <a:solidFill>
                   <a:srgbClr val="64748B"/>
                 </a:solidFill>
                 <a:latin typeface="Arial"/>
               </a:rPr>
-              <a:t>Un slot à ouvrir si 24e expert</a:t>
+              <a:t>25e capsule · lecteur à créer</a:t>
             </a:r>
           </a:p>
         </p:txBody>
@@ -5395,8 +5548,8 @@
         </p:nvSpPr>
         <p:spPr>
           <a:xfrm>
-            <a:off x="6047841" y="1335024"/>
-            <a:ext cx="2411272" cy="2487168"/>
+            <a:off x="4727448" y="1335024"/>
+            <a:ext cx="1751076" cy="2487168"/>
           </a:xfrm>
           <a:prstGeom prst="roundRect">
             <a:avLst>
@@ -5441,8 +5594,8 @@
         </p:nvSpPr>
         <p:spPr>
           <a:xfrm>
-            <a:off x="7015734" y="1517904"/>
-            <a:ext cx="475488" cy="475488"/>
+            <a:off x="5383529" y="1517904"/>
+            <a:ext cx="438912" cy="438912"/>
           </a:xfrm>
           <a:prstGeom prst="ellipse">
             <a:avLst/>
@@ -5475,7 +5628,7 @@
           <a:p>
             <a:pPr algn="ctr"/>
             <a:r>
-              <a:rPr sz="1800" b="1">
+              <a:rPr sz="1600" b="1">
                 <a:solidFill>
                   <a:srgbClr val="FFFFFF"/>
                 </a:solidFill>
@@ -5494,8 +5647,8 @@
         </p:nvSpPr>
         <p:spPr>
           <a:xfrm>
-            <a:off x="6194145" y="2121408"/>
-            <a:ext cx="2118664" cy="237744"/>
+            <a:off x="4837176" y="2084831"/>
+            <a:ext cx="1531620" cy="256032"/>
           </a:xfrm>
           <a:prstGeom prst="rect">
             <a:avLst/>
@@ -5510,13 +5663,13 @@
           <a:p>
             <a:pPr algn="ctr"/>
             <a:r>
-              <a:rPr sz="1250" b="1">
+              <a:rPr sz="1150" b="1">
                 <a:solidFill>
                   <a:srgbClr val="35BA84"/>
                 </a:solidFill>
                 <a:latin typeface="Arial"/>
               </a:rPr>
-              <a:t>Périmètre SPOC / MOOC</a:t>
+              <a:t>Scripts intro / outro</a:t>
             </a:r>
           </a:p>
         </p:txBody>
@@ -5529,8 +5682,8 @@
         </p:nvSpPr>
         <p:spPr>
           <a:xfrm>
-            <a:off x="6212433" y="2395728"/>
-            <a:ext cx="2082088" cy="566928"/>
+            <a:off x="4855464" y="2377439"/>
+            <a:ext cx="1495044" cy="621792"/>
           </a:xfrm>
           <a:prstGeom prst="rect">
             <a:avLst/>
@@ -5545,13 +5698,13 @@
           <a:p>
             <a:pPr algn="ctr"/>
             <a:r>
-              <a:rPr sz="950" b="0">
+              <a:rPr sz="900" b="0">
                 <a:solidFill>
                   <a:srgbClr val="475569"/>
                 </a:solidFill>
                 <a:latin typeface="Arial"/>
               </a:rPr>
-              <a:t>Aucune différenciation à ce jour : les paquets sont en variante unique.</a:t>
+              <a:t>À valider avant mi-octobre, tournage derrière.</a:t>
             </a:r>
           </a:p>
         </p:txBody>
@@ -5564,8 +5717,8 @@
         </p:nvSpPr>
         <p:spPr>
           <a:xfrm>
-            <a:off x="6194145" y="3054096"/>
-            <a:ext cx="2118664" cy="237744"/>
+            <a:off x="4837176" y="3072384"/>
+            <a:ext cx="1531620" cy="256032"/>
           </a:xfrm>
           <a:prstGeom prst="rect">
             <a:avLst/>
@@ -5580,13 +5733,13 @@
           <a:p>
             <a:pPr algn="ctr"/>
             <a:r>
-              <a:rPr sz="1100" b="1">
+              <a:rPr sz="950" b="1">
                 <a:solidFill>
                   <a:srgbClr val="2A346D"/>
                 </a:solidFill>
                 <a:latin typeface="Arial"/>
               </a:rPr>
-              <a:t>Fixe les seuils de réussite</a:t>
+              <a:t>76 segments à produire</a:t>
             </a:r>
           </a:p>
         </p:txBody>
@@ -5599,8 +5752,8 @@
         </p:nvSpPr>
         <p:spPr>
           <a:xfrm>
-            <a:off x="6212433" y="3328416"/>
-            <a:ext cx="2082088" cy="365760"/>
+            <a:off x="4855464" y="3364992"/>
+            <a:ext cx="1495044" cy="384048"/>
           </a:xfrm>
           <a:prstGeom prst="rect">
             <a:avLst/>
@@ -5615,13 +5768,13 @@
           <a:p>
             <a:pPr algn="ctr"/>
             <a:r>
-              <a:rPr sz="850" b="0">
+              <a:rPr sz="800" b="0">
                 <a:solidFill>
                   <a:srgbClr val="64748B"/>
                 </a:solidFill>
                 <a:latin typeface="Arial"/>
               </a:rPr>
-              <a:t>À trancher avant production des quiz</a:t>
+              <a:t>38 vidéos × intro + outro</a:t>
             </a:r>
           </a:p>
         </p:txBody>
@@ -5629,6 +5782,245 @@
       <p:sp>
         <p:nvSpPr>
           <p:cNvPr id="22" name="Rounded Rectangle 21"/>
+          <p:cNvSpPr/>
+          <p:nvPr/>
+        </p:nvSpPr>
+        <p:spPr>
+          <a:xfrm>
+            <a:off x="6707124" y="1335024"/>
+            <a:ext cx="1751076" cy="2487168"/>
+          </a:xfrm>
+          <a:prstGeom prst="roundRect">
+            <a:avLst>
+              <a:gd name="adj" fmla="val 16667"/>
+            </a:avLst>
+          </a:prstGeom>
+          <a:noFill/>
+          <a:ln w="15875">
+            <a:solidFill>
+              <a:srgbClr val="2A346D"/>
+            </a:solidFill>
+          </a:ln>
+          <a:effectLst/>
+        </p:spPr>
+        <p:style>
+          <a:lnRef idx="1">
+            <a:schemeClr val="accent1"/>
+          </a:lnRef>
+          <a:fillRef idx="3">
+            <a:schemeClr val="accent1"/>
+          </a:fillRef>
+          <a:effectRef idx="2">
+            <a:schemeClr val="accent1"/>
+          </a:effectRef>
+          <a:fontRef idx="minor">
+            <a:schemeClr val="lt1"/>
+          </a:fontRef>
+        </p:style>
+        <p:txBody>
+          <a:bodyPr rtlCol="0" anchor="ctr" wrap="square"/>
+          <a:lstStyle/>
+          <a:p>
+            <a:pPr algn="ctr"/>
+          </a:p>
+        </p:txBody>
+      </p:sp>
+      <p:sp>
+        <p:nvSpPr>
+          <p:cNvPr id="23" name="Oval 22"/>
+          <p:cNvSpPr/>
+          <p:nvPr/>
+        </p:nvSpPr>
+        <p:spPr>
+          <a:xfrm>
+            <a:off x="7363206" y="1517904"/>
+            <a:ext cx="438912" cy="438912"/>
+          </a:xfrm>
+          <a:prstGeom prst="ellipse">
+            <a:avLst/>
+          </a:prstGeom>
+          <a:solidFill>
+            <a:srgbClr val="2A346D"/>
+          </a:solidFill>
+          <a:ln>
+            <a:noFill/>
+          </a:ln>
+          <a:effectLst/>
+        </p:spPr>
+        <p:style>
+          <a:lnRef idx="1">
+            <a:schemeClr val="accent1"/>
+          </a:lnRef>
+          <a:fillRef idx="3">
+            <a:schemeClr val="accent1"/>
+          </a:fillRef>
+          <a:effectRef idx="2">
+            <a:schemeClr val="accent1"/>
+          </a:effectRef>
+          <a:fontRef idx="minor">
+            <a:schemeClr val="lt1"/>
+          </a:fontRef>
+        </p:style>
+        <p:txBody>
+          <a:bodyPr rtlCol="0" anchor="ctr" wrap="none" lIns="0" rIns="0" tIns="0" bIns="0"/>
+          <a:lstStyle/>
+          <a:p>
+            <a:pPr algn="ctr"/>
+            <a:r>
+              <a:rPr sz="1600" b="1">
+                <a:solidFill>
+                  <a:srgbClr val="FFFFFF"/>
+                </a:solidFill>
+                <a:latin typeface="Arial"/>
+              </a:rPr>
+              <a:t>4</a:t>
+            </a:r>
+          </a:p>
+        </p:txBody>
+      </p:sp>
+      <p:sp>
+        <p:nvSpPr>
+          <p:cNvPr id="24" name="TextBox 23"/>
+          <p:cNvSpPr txBox="1"/>
+          <p:nvPr/>
+        </p:nvSpPr>
+        <p:spPr>
+          <a:xfrm>
+            <a:off x="6816852" y="2084831"/>
+            <a:ext cx="1531620" cy="256032"/>
+          </a:xfrm>
+          <a:prstGeom prst="rect">
+            <a:avLst/>
+          </a:prstGeom>
+          <a:noFill/>
+        </p:spPr>
+        <p:txBody>
+          <a:bodyPr wrap="square" lIns="0" rIns="0" tIns="0" bIns="0" anchor="t">
+            <a:spAutoFit/>
+          </a:bodyPr>
+          <a:lstStyle/>
+          <a:p>
+            <a:pPr algn="ctr"/>
+            <a:r>
+              <a:rPr sz="1150" b="1">
+                <a:solidFill>
+                  <a:srgbClr val="2A346D"/>
+                </a:solidFill>
+                <a:latin typeface="Arial"/>
+              </a:rPr>
+              <a:t>Charge des quiz</a:t>
+            </a:r>
+          </a:p>
+        </p:txBody>
+      </p:sp>
+      <p:sp>
+        <p:nvSpPr>
+          <p:cNvPr id="25" name="TextBox 24"/>
+          <p:cNvSpPr txBox="1"/>
+          <p:nvPr/>
+        </p:nvSpPr>
+        <p:spPr>
+          <a:xfrm>
+            <a:off x="6835140" y="2377439"/>
+            <a:ext cx="1495044" cy="621792"/>
+          </a:xfrm>
+          <a:prstGeom prst="rect">
+            <a:avLst/>
+          </a:prstGeom>
+          <a:noFill/>
+        </p:spPr>
+        <p:txBody>
+          <a:bodyPr wrap="square" lIns="0" rIns="0" tIns="0" bIns="0" anchor="t">
+            <a:spAutoFit/>
+          </a:bodyPr>
+          <a:lstStyle/>
+          <a:p>
+            <a:pPr algn="ctr"/>
+            <a:r>
+              <a:rPr sz="900" b="0">
+                <a:solidFill>
+                  <a:srgbClr val="475569"/>
+                </a:solidFill>
+                <a:latin typeface="Arial"/>
+              </a:rPr>
+              <a:t>Aucune estimation de charge à ce jour.</a:t>
+            </a:r>
+          </a:p>
+        </p:txBody>
+      </p:sp>
+      <p:sp>
+        <p:nvSpPr>
+          <p:cNvPr id="26" name="TextBox 25"/>
+          <p:cNvSpPr txBox="1"/>
+          <p:nvPr/>
+        </p:nvSpPr>
+        <p:spPr>
+          <a:xfrm>
+            <a:off x="6816852" y="3072384"/>
+            <a:ext cx="1531620" cy="256032"/>
+          </a:xfrm>
+          <a:prstGeom prst="rect">
+            <a:avLst/>
+          </a:prstGeom>
+          <a:noFill/>
+        </p:spPr>
+        <p:txBody>
+          <a:bodyPr wrap="square" lIns="0" rIns="0" tIns="0" bIns="0" anchor="t">
+            <a:spAutoFit/>
+          </a:bodyPr>
+          <a:lstStyle/>
+          <a:p>
+            <a:pPr algn="ctr"/>
+            <a:r>
+              <a:rPr sz="950" b="1">
+                <a:solidFill>
+                  <a:srgbClr val="2A346D"/>
+                </a:solidFill>
+                <a:latin typeface="Arial"/>
+              </a:rPr>
+              <a:t>13 formatifs + 1 finale</a:t>
+            </a:r>
+          </a:p>
+        </p:txBody>
+      </p:sp>
+      <p:sp>
+        <p:nvSpPr>
+          <p:cNvPr id="27" name="TextBox 26"/>
+          <p:cNvSpPr txBox="1"/>
+          <p:nvPr/>
+        </p:nvSpPr>
+        <p:spPr>
+          <a:xfrm>
+            <a:off x="6835140" y="3364992"/>
+            <a:ext cx="1495044" cy="384048"/>
+          </a:xfrm>
+          <a:prstGeom prst="rect">
+            <a:avLst/>
+          </a:prstGeom>
+          <a:noFill/>
+        </p:spPr>
+        <p:txBody>
+          <a:bodyPr wrap="square" lIns="0" rIns="0" tIns="0" bIns="0" anchor="t">
+            <a:spAutoFit/>
+          </a:bodyPr>
+          <a:lstStyle/>
+          <a:p>
+            <a:pPr algn="ctr"/>
+            <a:r>
+              <a:rPr sz="800" b="0">
+                <a:solidFill>
+                  <a:srgbClr val="64748B"/>
+                </a:solidFill>
+                <a:latin typeface="Arial"/>
+              </a:rPr>
+              <a:t>évaluation sommative · 0 implémenté</a:t>
+            </a:r>
+          </a:p>
+        </p:txBody>
+      </p:sp>
+      <p:sp>
+        <p:nvSpPr>
+          <p:cNvPr id="28" name="Rounded Rectangle 27"/>
           <p:cNvSpPr/>
           <p:nvPr/>
         </p:nvSpPr>
@@ -5676,7 +6068,7 @@
       </p:sp>
       <p:sp>
         <p:nvSpPr>
-          <p:cNvPr id="23" name="TextBox 22"/>
+          <p:cNvPr id="29" name="TextBox 28"/>
           <p:cNvSpPr txBox="1"/>
           <p:nvPr/>
         </p:nvSpPr>
@@ -5711,7 +6103,7 @@
       </p:sp>
       <p:sp>
         <p:nvSpPr>
-          <p:cNvPr id="24" name="TextBox 23"/>
+          <p:cNvPr id="30" name="TextBox 29"/>
           <p:cNvSpPr txBox="1"/>
           <p:nvPr/>
         </p:nvSpPr>
@@ -5746,7 +6138,7 @@
       </p:sp>
       <p:sp>
         <p:nvSpPr>
-          <p:cNvPr id="25" name="TextBox 24"/>
+          <p:cNvPr id="31" name="TextBox 30"/>
           <p:cNvSpPr txBox="1"/>
           <p:nvPr/>
         </p:nvSpPr>
@@ -6033,7 +6425,7 @@
                 </a:solidFill>
                 <a:latin typeface="Arial"/>
               </a:rPr>
-              <a:t>Rushes experts complets · intégrable dès validation des V1/V0</a:t>
+              <a:t>Rushes complets · sous réserve du rattachement de la capsule PACTE</a:t>
             </a:r>
           </a:p>
         </p:txBody>
@@ -6445,7 +6837,7 @@
                 </a:solidFill>
                 <a:latin typeface="Arial"/>
               </a:rPr>
-              <a:t>Suspendu à la décision sur E12 / E14 — aucun rush disponible</a:t>
+              <a:t>Suspendu à E12 / E14 · E13bis tournée, E13 et E15 le 24/09</a:t>
             </a:r>
           </a:p>
         </p:txBody>
@@ -6786,7 +7178,7 @@
                 </a:solidFill>
                 <a:latin typeface="Arial"/>
               </a:rPr>
-              <a:t>Sous réserve que E12 / E14 soient tournées en octobre</a:t>
+              <a:t>Sous réserve de E12 / E14 en octobre et du volume intro / outro</a:t>
             </a:r>
           </a:p>
         </p:txBody>
@@ -6808,11 +7200,11 @@
             </a:avLst>
           </a:prstGeom>
           <a:solidFill>
-            <a:srgbClr val="F9ECF4"/>
+            <a:srgbClr val="EEF1F8"/>
           </a:solidFill>
           <a:ln w="15875">
             <a:solidFill>
-              <a:srgbClr val="63003D"/>
+              <a:srgbClr val="2A346D"/>
             </a:solidFill>
           </a:ln>
           <a:effectLst/>
@@ -6863,13 +7255,13 @@
           <a:p>
             <a:pPr algn="l"/>
             <a:r>
-              <a:rPr sz="1000" b="1">
-                <a:solidFill>
-                  <a:srgbClr val="63003D"/>
-                </a:solidFill>
-                <a:latin typeface="Arial"/>
-              </a:rPr>
-              <a:t>Angle mort : 13 quiz d'évaluation formative et 1 évaluation sommative à produire — 0 implémenté dans M1 à M6, charge non estimée à ce jour.</a:t>
+              <a:rPr sz="1000" b="0">
+                <a:solidFill>
+                  <a:srgbClr val="2A346D"/>
+                </a:solidFill>
+                <a:latin typeface="Arial"/>
+              </a:rPr>
+              <a:t>Périmètre : SPOC Paris-Saclay — le terme « MOOC » est conservé en communication. Une éventuelle déclinaison à périmètre élargi est un sujet ultérieur du projet.</a:t>
             </a:r>
           </a:p>
         </p:txBody>
@@ -6904,7 +7296,7 @@
                 </a:solidFill>
                 <a:latin typeface="Arial"/>
               </a:rPr>
-              <a:t>Hypothèses : montage V0 ≈ 3 sem. après tournage · 1 cycle de validation (2 + 2 sem.) · aucun re-tournage · 2 sem. de recette LMS.</a:t>
+              <a:t>Hypothèses : montage V0 ≈ 3 sem. · validation 2 + 2 sem. · recette LMS 2 sem. · 76 intro / outro non chiffrés.</a:t>
             </a:r>
           </a:p>
         </p:txBody>

</xml_diff>

<commit_message>
Aligner les capsules expert sur le numéro de cadre à partir de V14.
E13bis devient E14 (Yoann) et les suivantes avancent d’un cran, jusqu’à E25. L’interface reprend aussi les couleurs de la charte.

Co-authored-by: Cursor <cursoragent@cursor.com>
</commit_message>
<xml_diff>
--- a/avancement-mooc-2026-09-22.pptx
+++ b/avancement-mooc-2026-09-22.pptx
@@ -5191,7 +5191,7 @@
                 </a:solidFill>
                 <a:latin typeface="Arial"/>
               </a:rPr>
-              <a:t>E12 / E14</a:t>
+              <a:t>E15 / E16</a:t>
             </a:r>
           </a:p>
         </p:txBody>
@@ -5226,7 +5226,7 @@
                 </a:solidFill>
                 <a:latin typeface="Arial"/>
               </a:rPr>
-              <a:t>Capsules Fatoumata, non importées en V0 et absentes du 24/09.</a:t>
+              <a:t>E12 est Stéphanie Augéroussel (SATT), pas Fatoumata. Restent E15 Fatoumata et E16.</a:t>
             </a:r>
           </a:p>
         </p:txBody>
@@ -5261,7 +5261,7 @@
                 </a:solidFill>
                 <a:latin typeface="Arial"/>
               </a:rPr>
-              <a:t>Bloque le module 3</a:t>
+              <a:t>Bloque le T8</a:t>
             </a:r>
           </a:p>
         </p:txBody>
@@ -5296,7 +5296,7 @@
                 </a:solidFill>
                 <a:latin typeface="Arial"/>
               </a:rPr>
-              <a:t>T7 et T8 incomplets</a:t>
+              <a:t>E12 à brancher (lecteur)</a:t>
             </a:r>
           </a:p>
         </p:txBody>
@@ -6096,7 +6096,7 @@
                 </a:solidFill>
                 <a:latin typeface="Arial"/>
               </a:rPr>
-              <a:t>À confirmer : E3 (Burgé) est annoncé « courant octobre » tout en figurant au plateau du 24/09. Plateau du 24/09 à IncubAlliance : 7 capsules (E2, E3, E4, E13, E15, E17, E18).</a:t>
+              <a:t>À confirmer : E3 (Burgé) est annoncé « courant octobre » tout en figurant au plateau du 24/09. Plateau du 24/09 à IncubAlliance : 7 capsules (E2, E3, E4, E13, E16, E18, E19).</a:t>
             </a:r>
           </a:p>
         </p:txBody>
@@ -6131,7 +6131,7 @@
                 </a:solidFill>
                 <a:latin typeface="Arial"/>
               </a:rPr>
-              <a:t>Si le plateau du 24/09 se déroule complet, il ne restera que E12 et E14 à planifier.</a:t>
+              <a:t>E14 = Yoann (V14). Il reste E15 Fatoumata et E16 à planifier.</a:t>
             </a:r>
           </a:p>
         </p:txBody>
@@ -6631,7 +6631,7 @@
                 </a:solidFill>
                 <a:latin typeface="Arial"/>
               </a:rPr>
-              <a:t>Débloqué par le plateau du 24/09 : E2, E3, E4, E17, E18</a:t>
+              <a:t>Débloqué par le plateau du 24/09 : E2, E3, E4, E18, E19</a:t>
             </a:r>
           </a:p>
         </p:txBody>
@@ -6837,7 +6837,7 @@
                 </a:solidFill>
                 <a:latin typeface="Arial"/>
               </a:rPr>
-              <a:t>Suspendu à E12 / E14 · E13bis tournée, E13 et E15 le 24/09</a:t>
+              <a:t>E14 = Yoann (cadre V14). Restent E15 Fatoumata et E16.</a:t>
             </a:r>
           </a:p>
         </p:txBody>
@@ -7178,7 +7178,7 @@
                 </a:solidFill>
                 <a:latin typeface="Arial"/>
               </a:rPr>
-              <a:t>Sous réserve de E12 / E14 en octobre et du volume intro / outro</a:t>
+              <a:t>Sous réserve de E15 Fatoumata, E16, et du volume intro / outro</a:t>
             </a:r>
           </a:p>
         </p:txBody>

</xml_diff>